<commit_message>
Fix Both .py Files and EDA_analysis file
</commit_message>
<xml_diff>
--- a/presentation/online_retail_sales_insights.pptx
+++ b/presentation/online_retail_sales_insights.pptx
@@ -119,6 +119,11 @@
       </a:defRPr>
     </a:lvl9pPr>
   </p:defaultTextStyle>
+  <p:extLst>
+    <p:ext uri="{EFAFB233-063F-42B5-8137-9DF3F51BA10A}">
+      <p15:sldGuideLst xmlns:p15="http://schemas.microsoft.com/office/powerpoint/2012/main"/>
+    </p:ext>
+  </p:extLst>
 </p:presentation>
 </file>
 
@@ -204,7 +209,7 @@
           <a:p>
             <a:fld id="{CB3EFB48-11E4-43CB-B93F-67B84E04AE07}" type="datetimeFigureOut">
               <a:rPr lang="en-IN" smtClean="0"/>
-              <a:t>02-04-2026</a:t>
+              <a:t>18-06-2026</a:t>
             </a:fld>
             <a:endParaRPr lang="en-IN" dirty="0"/>
           </a:p>
@@ -705,7 +710,7 @@
           <a:p>
             <a:fld id="{F8DC09E1-D8B1-46BC-A23D-FD031ADC7462}" type="datetimeFigureOut">
               <a:rPr lang="en-IN" smtClean="0"/>
-              <a:t>02-04-2026</a:t>
+              <a:t>18-06-2026</a:t>
             </a:fld>
             <a:endParaRPr lang="en-IN" dirty="0"/>
           </a:p>
@@ -905,7 +910,7 @@
           <a:p>
             <a:fld id="{F8DC09E1-D8B1-46BC-A23D-FD031ADC7462}" type="datetimeFigureOut">
               <a:rPr lang="en-IN" smtClean="0"/>
-              <a:t>02-04-2026</a:t>
+              <a:t>18-06-2026</a:t>
             </a:fld>
             <a:endParaRPr lang="en-IN" dirty="0"/>
           </a:p>
@@ -1115,7 +1120,7 @@
           <a:p>
             <a:fld id="{F8DC09E1-D8B1-46BC-A23D-FD031ADC7462}" type="datetimeFigureOut">
               <a:rPr lang="en-IN" smtClean="0"/>
-              <a:t>02-04-2026</a:t>
+              <a:t>18-06-2026</a:t>
             </a:fld>
             <a:endParaRPr lang="en-IN" dirty="0"/>
           </a:p>
@@ -1315,7 +1320,7 @@
           <a:p>
             <a:fld id="{F8DC09E1-D8B1-46BC-A23D-FD031ADC7462}" type="datetimeFigureOut">
               <a:rPr lang="en-IN" smtClean="0"/>
-              <a:t>02-04-2026</a:t>
+              <a:t>18-06-2026</a:t>
             </a:fld>
             <a:endParaRPr lang="en-IN" dirty="0"/>
           </a:p>
@@ -1591,7 +1596,7 @@
           <a:p>
             <a:fld id="{F8DC09E1-D8B1-46BC-A23D-FD031ADC7462}" type="datetimeFigureOut">
               <a:rPr lang="en-IN" smtClean="0"/>
-              <a:t>02-04-2026</a:t>
+              <a:t>18-06-2026</a:t>
             </a:fld>
             <a:endParaRPr lang="en-IN" dirty="0"/>
           </a:p>
@@ -1859,7 +1864,7 @@
           <a:p>
             <a:fld id="{F8DC09E1-D8B1-46BC-A23D-FD031ADC7462}" type="datetimeFigureOut">
               <a:rPr lang="en-IN" smtClean="0"/>
-              <a:t>02-04-2026</a:t>
+              <a:t>18-06-2026</a:t>
             </a:fld>
             <a:endParaRPr lang="en-IN" dirty="0"/>
           </a:p>
@@ -2274,7 +2279,7 @@
           <a:p>
             <a:fld id="{F8DC09E1-D8B1-46BC-A23D-FD031ADC7462}" type="datetimeFigureOut">
               <a:rPr lang="en-IN" smtClean="0"/>
-              <a:t>02-04-2026</a:t>
+              <a:t>18-06-2026</a:t>
             </a:fld>
             <a:endParaRPr lang="en-IN" dirty="0"/>
           </a:p>
@@ -2416,7 +2421,7 @@
           <a:p>
             <a:fld id="{F8DC09E1-D8B1-46BC-A23D-FD031ADC7462}" type="datetimeFigureOut">
               <a:rPr lang="en-IN" smtClean="0"/>
-              <a:t>02-04-2026</a:t>
+              <a:t>18-06-2026</a:t>
             </a:fld>
             <a:endParaRPr lang="en-IN" dirty="0"/>
           </a:p>
@@ -2529,7 +2534,7 @@
           <a:p>
             <a:fld id="{F8DC09E1-D8B1-46BC-A23D-FD031ADC7462}" type="datetimeFigureOut">
               <a:rPr lang="en-IN" smtClean="0"/>
-              <a:t>02-04-2026</a:t>
+              <a:t>18-06-2026</a:t>
             </a:fld>
             <a:endParaRPr lang="en-IN" dirty="0"/>
           </a:p>
@@ -2842,7 +2847,7 @@
           <a:p>
             <a:fld id="{F8DC09E1-D8B1-46BC-A23D-FD031ADC7462}" type="datetimeFigureOut">
               <a:rPr lang="en-IN" smtClean="0"/>
-              <a:t>02-04-2026</a:t>
+              <a:t>18-06-2026</a:t>
             </a:fld>
             <a:endParaRPr lang="en-IN" dirty="0"/>
           </a:p>
@@ -3131,7 +3136,7 @@
           <a:p>
             <a:fld id="{F8DC09E1-D8B1-46BC-A23D-FD031ADC7462}" type="datetimeFigureOut">
               <a:rPr lang="en-IN" smtClean="0"/>
-              <a:t>02-04-2026</a:t>
+              <a:t>18-06-2026</a:t>
             </a:fld>
             <a:endParaRPr lang="en-IN" dirty="0"/>
           </a:p>
@@ -3374,7 +3379,7 @@
           <a:p>
             <a:fld id="{F8DC09E1-D8B1-46BC-A23D-FD031ADC7462}" type="datetimeFigureOut">
               <a:rPr lang="en-IN" smtClean="0"/>
-              <a:t>02-04-2026</a:t>
+              <a:t>18-06-2026</a:t>
             </a:fld>
             <a:endParaRPr lang="en-IN" dirty="0"/>
           </a:p>
@@ -4316,6 +4321,15 @@
         <p:blipFill>
           <a:blip r:embed="rId2">
             <a:extLst>
+              <a:ext uri="{BEBA8EAE-BF5A-486C-A8C5-ECC9F3942E4B}">
+                <a14:imgProps xmlns:a14="http://schemas.microsoft.com/office/drawing/2010/main">
+                  <a14:imgLayer r:embed="rId3">
+                    <a14:imgEffect>
+                      <a14:saturation sat="33000"/>
+                    </a14:imgEffect>
+                  </a14:imgLayer>
+                </a14:imgProps>
+              </a:ext>
               <a:ext uri="{28A0092B-C50C-407E-A947-70E740481C1C}">
                 <a14:useLocalDpi xmlns:a14="http://schemas.microsoft.com/office/drawing/2010/main" val="0"/>
               </a:ext>

</xml_diff>